<commit_message>
Deck Tirabasso: foto della Galleria Subalpina nella slide di Torino
La foto è di Isiwal, da Wikimedia Commons, con licenza CC BY-SA 4.0:
il credito è sulla slide e nelle note.

Co-Authored-By: Claude Opus 5.5 <noreply@anthropic.com>
Claude-Session: https://claude.ai/code/session_019CimPMJNPswxhYiugHUDKX
</commit_message>
<xml_diff>
--- a/tirabasso/campagna-fw26-27/Tirabasso_Un_inverno_a_Parigi.pptx
+++ b/tirabasso/campagna-fw26-27/Tirabasso_Un_inverno_a_Parigi.pptx
@@ -1047,7 +1047,7 @@
           <a:p>
             <a:r>
               <a:rPr lang="en-US" dirty="0"/>
-              <a:t>Immagine: riferimento dalla cartella di ricerca, non uno scatto di Torino.</a:t>
+              <a:t>Immagine: Galleria Subalpina, Torino (settembre 2015). Autore Isiwal, Wikimedia Commons, licenza CC BY-SA 4.0: il credito va mantenuto.</a:t>
             </a:r>
             <a:endParaRPr lang="en-US" dirty="0"/>
           </a:p>
@@ -6285,7 +6285,7 @@
       </p:grpSpPr>
       <p:pic>
         <p:nvPicPr>
-          <p:cNvPr id="2" name="Image 0" descr="img/column.jpg">    </p:cNvPr>
+          <p:cNvPr id="2" name="Image 0" descr="img/torino.jpg">    </p:cNvPr>
           <p:cNvPicPr>
             <a:picLocks noChangeAspect="1"/>
           </p:cNvPicPr>
@@ -6293,7 +6293,7 @@
         </p:nvPicPr>
         <p:blipFill>
           <a:blip r:embed="rId1"/>
-          <a:srcRect l="10519" r="24543" t="0" b="0"/>
+          <a:srcRect l="3028" r="3028" t="0" b="0"/>
           <a:stretch/>
         </p:blipFill>
         <p:spPr>
@@ -7157,8 +7157,8 @@
         </p:nvSpPr>
         <p:spPr>
           <a:xfrm>
-            <a:off x="685800" y="6217920"/>
-            <a:ext cx="7772400" cy="274320"/>
+            <a:off x="685800" y="6080760"/>
+            <a:ext cx="7772400" cy="228600"/>
           </a:xfrm>
           <a:prstGeom prst="rect">
             <a:avLst/>
@@ -7185,6 +7185,45 @@
               <a:t>Permessi: Comune di Torino, con il supporto di Film Commission Torino Piemonte. Location da verificare in sopralluogo.</a:t>
             </a:r>
             <a:endParaRPr lang="en-US" sz="1050" dirty="0"/>
+          </a:p>
+        </p:txBody>
+      </p:sp>
+      <p:sp>
+        <p:nvSpPr>
+          <p:cNvPr id="28" name="Text 25"/>
+          <p:cNvSpPr txBox="1"/>
+          <p:nvPr/>
+        </p:nvSpPr>
+        <p:spPr>
+          <a:xfrm>
+            <a:off x="685800" y="6327648"/>
+            <a:ext cx="7772400" cy="228600"/>
+          </a:xfrm>
+          <a:prstGeom prst="rect">
+            <a:avLst/>
+          </a:prstGeom>
+          <a:noFill/>
+          <a:ln/>
+        </p:spPr>
+        <p:txBody>
+          <a:bodyPr wrap="square" lIns="0" tIns="0" rIns="0" bIns="0" rtlCol="0" anchor="t"/>
+          <a:lstStyle/>
+          <a:p>
+            <a:pPr indent="0" marL="0">
+              <a:buNone/>
+            </a:pPr>
+            <a:r>
+              <a:rPr lang="en-US" sz="950" dirty="0">
+                <a:solidFill>
+                  <a:srgbClr val="8A8474"/>
+                </a:solidFill>
+                <a:latin typeface="Titillium Web Light" pitchFamily="34" charset="0"/>
+                <a:ea typeface="Titillium Web Light" pitchFamily="34" charset="-122"/>
+                <a:cs typeface="Titillium Web Light" pitchFamily="34" charset="-120"/>
+              </a:rPr>
+              <a:t>Foto: Galleria Subalpina, Torino. Isiwal / Wikimedia Commons, CC BY-SA 4.0</a:t>
+            </a:r>
+            <a:endParaRPr lang="en-US" sz="950" dirty="0"/>
           </a:p>
         </p:txBody>
       </p:sp>

</xml_diff>